<commit_message>
Add slide on type erasure
</commit_message>
<xml_diff>
--- a/cpp_software_engineering.pptx
+++ b/cpp_software_engineering.pptx
@@ -5,7 +5,7 @@
     <p:sldMasterId id="2147483648" r:id="rId1"/>
   </p:sldMasterIdLst>
   <p:notesMasterIdLst>
-    <p:notesMasterId r:id="rId64"/>
+    <p:notesMasterId r:id="rId65"/>
   </p:notesMasterIdLst>
   <p:sldIdLst>
     <p:sldId id="257" r:id="rId2"/>
@@ -65,11 +65,12 @@
     <p:sldId id="396" r:id="rId56"/>
     <p:sldId id="398" r:id="rId57"/>
     <p:sldId id="397" r:id="rId58"/>
-    <p:sldId id="415" r:id="rId59"/>
-    <p:sldId id="414" r:id="rId60"/>
-    <p:sldId id="391" r:id="rId61"/>
-    <p:sldId id="392" r:id="rId62"/>
-    <p:sldId id="393" r:id="rId63"/>
+    <p:sldId id="416" r:id="rId59"/>
+    <p:sldId id="415" r:id="rId60"/>
+    <p:sldId id="414" r:id="rId61"/>
+    <p:sldId id="391" r:id="rId62"/>
+    <p:sldId id="392" r:id="rId63"/>
+    <p:sldId id="393" r:id="rId64"/>
   </p:sldIdLst>
   <p:sldSz cx="12192000" cy="6858000"/>
   <p:notesSz cx="6858000" cy="9144000"/>
@@ -258,6 +259,7 @@
             <p14:sldId id="396"/>
             <p14:sldId id="398"/>
             <p14:sldId id="397"/>
+            <p14:sldId id="416"/>
             <p14:sldId id="415"/>
             <p14:sldId id="414"/>
             <p14:sldId id="391"/>
@@ -428,7 +430,7 @@
           <a:p>
             <a:fld id="{75E18316-3541-442E-8E76-B95A0AF605E0}" type="datetimeFigureOut">
               <a:rPr lang="LID4096" smtClean="0"/>
-              <a:t>04/30/2026</a:t>
+              <a:t>05/07/2026</a:t>
             </a:fld>
             <a:endParaRPr lang="LID4096"/>
           </a:p>
@@ -845,7 +847,7 @@
           <a:p>
             <a:fld id="{D4CCEB0E-618E-45C7-A579-AD180C33220D}" type="datetime1">
               <a:rPr lang="LID4096" smtClean="0"/>
-              <a:t>04/30/2026</a:t>
+              <a:t>05/07/2026</a:t>
             </a:fld>
             <a:endParaRPr lang="LID4096"/>
           </a:p>
@@ -1045,7 +1047,7 @@
           <a:p>
             <a:fld id="{8F9B0D5F-347B-4B69-9FE7-43363B46D130}" type="datetime1">
               <a:rPr lang="LID4096" smtClean="0"/>
-              <a:t>04/30/2026</a:t>
+              <a:t>05/07/2026</a:t>
             </a:fld>
             <a:endParaRPr lang="LID4096"/>
           </a:p>
@@ -1255,7 +1257,7 @@
           <a:p>
             <a:fld id="{A72936A9-07CF-4428-8F68-9DB53105CCBE}" type="datetime1">
               <a:rPr lang="LID4096" smtClean="0"/>
-              <a:t>04/30/2026</a:t>
+              <a:t>05/07/2026</a:t>
             </a:fld>
             <a:endParaRPr lang="LID4096"/>
           </a:p>
@@ -1455,7 +1457,7 @@
           <a:p>
             <a:fld id="{136170E8-8909-47C9-AECF-C7A110A9E262}" type="datetime1">
               <a:rPr lang="LID4096" smtClean="0"/>
-              <a:t>04/30/2026</a:t>
+              <a:t>05/07/2026</a:t>
             </a:fld>
             <a:endParaRPr lang="LID4096"/>
           </a:p>
@@ -1731,7 +1733,7 @@
           <a:p>
             <a:fld id="{D37C590D-7973-43C9-B207-04F7CE471508}" type="datetime1">
               <a:rPr lang="LID4096" smtClean="0"/>
-              <a:t>04/30/2026</a:t>
+              <a:t>05/07/2026</a:t>
             </a:fld>
             <a:endParaRPr lang="LID4096"/>
           </a:p>
@@ -1999,7 +2001,7 @@
           <a:p>
             <a:fld id="{D8E041D7-7EA6-423B-88A0-A217731AA946}" type="datetime1">
               <a:rPr lang="LID4096" smtClean="0"/>
-              <a:t>04/30/2026</a:t>
+              <a:t>05/07/2026</a:t>
             </a:fld>
             <a:endParaRPr lang="LID4096"/>
           </a:p>
@@ -2414,7 +2416,7 @@
           <a:p>
             <a:fld id="{1BDF2A55-FD61-4AC5-A515-ED3F1E80F296}" type="datetime1">
               <a:rPr lang="LID4096" smtClean="0"/>
-              <a:t>04/30/2026</a:t>
+              <a:t>05/07/2026</a:t>
             </a:fld>
             <a:endParaRPr lang="LID4096"/>
           </a:p>
@@ -2556,7 +2558,7 @@
           <a:p>
             <a:fld id="{AAED7C0E-94F0-4D14-8F58-6D25D315F3DC}" type="datetime1">
               <a:rPr lang="LID4096" smtClean="0"/>
-              <a:t>04/30/2026</a:t>
+              <a:t>05/07/2026</a:t>
             </a:fld>
             <a:endParaRPr lang="LID4096"/>
           </a:p>
@@ -2669,7 +2671,7 @@
           <a:p>
             <a:fld id="{2888AB77-1B4E-4D00-8D86-8CBF03A7E13C}" type="datetime1">
               <a:rPr lang="LID4096" smtClean="0"/>
-              <a:t>04/30/2026</a:t>
+              <a:t>05/07/2026</a:t>
             </a:fld>
             <a:endParaRPr lang="LID4096"/>
           </a:p>
@@ -2982,7 +2984,7 @@
           <a:p>
             <a:fld id="{013C0D7F-F788-458A-93D6-DCF4C7F29636}" type="datetime1">
               <a:rPr lang="LID4096" smtClean="0"/>
-              <a:t>04/30/2026</a:t>
+              <a:t>05/07/2026</a:t>
             </a:fld>
             <a:endParaRPr lang="LID4096"/>
           </a:p>
@@ -3271,7 +3273,7 @@
           <a:p>
             <a:fld id="{EEC7CCBC-154E-498D-B8FD-669CE3C64250}" type="datetime1">
               <a:rPr lang="LID4096" smtClean="0"/>
-              <a:t>04/30/2026</a:t>
+              <a:t>05/07/2026</a:t>
             </a:fld>
             <a:endParaRPr lang="LID4096"/>
           </a:p>
@@ -3514,7 +3516,7 @@
           <a:p>
             <a:fld id="{161B14D2-6539-4609-80C5-044F9B782269}" type="datetime1">
               <a:rPr lang="LID4096" smtClean="0"/>
-              <a:t>04/30/2026</a:t>
+              <a:t>05/07/2026</a:t>
             </a:fld>
             <a:endParaRPr lang="LID4096"/>
           </a:p>
@@ -21950,7 +21952,7 @@
           <a:p>
             <a:r>
               <a:rPr lang="en-US" dirty="0"/>
-              <a:t>Curiously, Repeating Template Pattern (CRTP)</a:t>
+              <a:t>Curiously Repeating Template Pattern (CRTP)</a:t>
             </a:r>
             <a:endParaRPr lang="LID4096" dirty="0"/>
           </a:p>
@@ -24877,7 +24879,7 @@
           <p:cNvPr id="2" name="Title 1">
             <a:extLst>
               <a:ext uri="{FF2B5EF4-FFF2-40B4-BE49-F238E27FC236}">
-                <a16:creationId xmlns:a16="http://schemas.microsoft.com/office/drawing/2014/main" id="{22597127-255D-E990-EC62-F84C40508FDD}"/>
+                <a16:creationId xmlns:a16="http://schemas.microsoft.com/office/drawing/2014/main" id="{95CDECD0-0D87-0E0C-4B67-0389A4F32313}"/>
               </a:ext>
             </a:extLst>
           </p:cNvPr>
@@ -24895,15 +24897,7 @@
           <a:p>
             <a:r>
               <a:rPr lang="en-US" dirty="0"/>
-              <a:t>Pointer to </a:t>
-            </a:r>
-            <a:r>
-              <a:rPr lang="en-US" dirty="0" err="1"/>
-              <a:t>IMPLementation</a:t>
-            </a:r>
-            <a:r>
-              <a:rPr lang="en-US" dirty="0"/>
-              <a:t> idiom (PIMPL)</a:t>
+              <a:t>Type erasure</a:t>
             </a:r>
             <a:endParaRPr lang="LID4096" dirty="0"/>
           </a:p>
@@ -24911,10 +24905,10 @@
       </p:sp>
       <p:sp>
         <p:nvSpPr>
-          <p:cNvPr id="3" name="Content Placeholder 2">
-            <a:extLst>
-              <a:ext uri="{FF2B5EF4-FFF2-40B4-BE49-F238E27FC236}">
-                <a16:creationId xmlns:a16="http://schemas.microsoft.com/office/drawing/2014/main" id="{BFC3B8FA-3708-5100-0EB8-21D5539B42F7}"/>
+          <p:cNvPr id="4" name="Content Placeholder 3">
+            <a:extLst>
+              <a:ext uri="{FF2B5EF4-FFF2-40B4-BE49-F238E27FC236}">
+                <a16:creationId xmlns:a16="http://schemas.microsoft.com/office/drawing/2014/main" id="{E9112DA9-CDE6-0025-7842-D90A446B2FCB}"/>
               </a:ext>
             </a:extLst>
           </p:cNvPr>
@@ -24932,7 +24926,7 @@
           <a:p>
             <a:r>
               <a:rPr lang="en-US" dirty="0"/>
-              <a:t>Interface holds pointer to implementation</a:t>
+              <a:t>Hides object's concrete implementation behind a uniform interface</a:t>
             </a:r>
           </a:p>
           <a:p>
@@ -24948,21 +24942,21 @@
             <a:pPr lvl="1"/>
             <a:r>
               <a:rPr lang="en-US" dirty="0"/>
-              <a:t>Decouple interface and implementation</a:t>
+              <a:t>No inheritance required</a:t>
             </a:r>
           </a:p>
           <a:p>
             <a:pPr lvl="1"/>
             <a:r>
               <a:rPr lang="en-US" dirty="0"/>
-              <a:t>Easy to replace implementation</a:t>
+              <a:t>Adding new concrete types is often easy (OCP)</a:t>
             </a:r>
           </a:p>
           <a:p>
             <a:pPr lvl="1"/>
             <a:r>
               <a:rPr lang="en-US" dirty="0"/>
-              <a:t>Reduces compile times (only implementation needs to be recompiled)</a:t>
+              <a:t>Facilitates lean interface (ISP)</a:t>
             </a:r>
             <a:endParaRPr lang="LID4096" dirty="0"/>
           </a:p>
@@ -24970,10 +24964,10 @@
       </p:sp>
       <p:sp>
         <p:nvSpPr>
-          <p:cNvPr id="4" name="Slide Number Placeholder 3">
-            <a:extLst>
-              <a:ext uri="{FF2B5EF4-FFF2-40B4-BE49-F238E27FC236}">
-                <a16:creationId xmlns:a16="http://schemas.microsoft.com/office/drawing/2014/main" id="{E9E5189A-6FE9-10F7-635D-516D82FAD1C8}"/>
+          <p:cNvPr id="3" name="Slide Number Placeholder 2">
+            <a:extLst>
+              <a:ext uri="{FF2B5EF4-FFF2-40B4-BE49-F238E27FC236}">
+                <a16:creationId xmlns:a16="http://schemas.microsoft.com/office/drawing/2014/main" id="{8FAD7232-77A9-0916-6958-774F5569EF98}"/>
               </a:ext>
             </a:extLst>
           </p:cNvPr>
@@ -24992,6 +24986,292 @@
             <a:fld id="{FDB1AA33-DFBB-49AC-8CEE-23FFECEB5648}" type="slidenum">
               <a:rPr lang="LID4096" smtClean="0"/>
               <a:t>58</a:t>
+            </a:fld>
+            <a:endParaRPr lang="LID4096"/>
+          </a:p>
+        </p:txBody>
+      </p:sp>
+      <p:sp>
+        <p:nvSpPr>
+          <p:cNvPr id="5" name="TextBox 4">
+            <a:extLst>
+              <a:ext uri="{FF2B5EF4-FFF2-40B4-BE49-F238E27FC236}">
+                <a16:creationId xmlns:a16="http://schemas.microsoft.com/office/drawing/2014/main" id="{7A7D808E-D01D-F65B-CBCB-3EC10A7A7AB2}"/>
+              </a:ext>
+            </a:extLst>
+          </p:cNvPr>
+          <p:cNvSpPr txBox="1"/>
+          <p:nvPr/>
+        </p:nvSpPr>
+        <p:spPr>
+          <a:xfrm>
+            <a:off x="499580" y="5791830"/>
+            <a:ext cx="9809160" cy="646331"/>
+          </a:xfrm>
+          <a:prstGeom prst="rect">
+            <a:avLst/>
+          </a:prstGeom>
+          <a:noFill/>
+          <a:ln>
+            <a:solidFill>
+              <a:schemeClr val="tx1"/>
+            </a:solidFill>
+          </a:ln>
+        </p:spPr>
+        <p:txBody>
+          <a:bodyPr wrap="none" rtlCol="0">
+            <a:spAutoFit/>
+          </a:bodyPr>
+          <a:lstStyle/>
+          <a:p>
+            <a:r>
+              <a:rPr lang="en-US" sz="2000" dirty="0"/>
+              <a:t>See</a:t>
+            </a:r>
+            <a:br>
+              <a:rPr lang="en-US" sz="2000" dirty="0"/>
+            </a:br>
+            <a:r>
+              <a:rPr lang="en-US" sz="1600" dirty="0">
+                <a:hlinkClick r:id="rId2"/>
+              </a:rPr>
+              <a:t>https://github.com/gjbex/Scientific-C-plus-plus/tree/master/source-code/Templates/Shapes/TypeErasure</a:t>
+            </a:r>
+            <a:r>
+              <a:rPr lang="en-US" sz="1600" dirty="0"/>
+              <a:t> </a:t>
+            </a:r>
+          </a:p>
+        </p:txBody>
+      </p:sp>
+    </p:spTree>
+    <p:extLst>
+      <p:ext uri="{BB962C8B-B14F-4D97-AF65-F5344CB8AC3E}">
+        <p14:creationId xmlns:p14="http://schemas.microsoft.com/office/powerpoint/2010/main" val="2076464513"/>
+      </p:ext>
+    </p:extLst>
+  </p:cSld>
+  <p:clrMapOvr>
+    <a:masterClrMapping/>
+  </p:clrMapOvr>
+  <p:timing>
+    <p:tnLst>
+      <p:par>
+        <p:cTn id="1" dur="indefinite" restart="never" nodeType="tmRoot">
+          <p:childTnLst>
+            <p:seq concurrent="1" nextAc="seek">
+              <p:cTn id="2" dur="indefinite" nodeType="mainSeq">
+                <p:childTnLst>
+                  <p:par>
+                    <p:cTn id="3" fill="hold">
+                      <p:stCondLst>
+                        <p:cond delay="indefinite"/>
+                      </p:stCondLst>
+                      <p:childTnLst>
+                        <p:par>
+                          <p:cTn id="4" fill="hold">
+                            <p:stCondLst>
+                              <p:cond delay="0"/>
+                            </p:stCondLst>
+                            <p:childTnLst>
+                              <p:par>
+                                <p:cTn id="5" presetID="1" presetClass="entr" presetSubtype="0" fill="hold" grpId="0" nodeType="clickEffect">
+                                  <p:stCondLst>
+                                    <p:cond delay="0"/>
+                                  </p:stCondLst>
+                                  <p:childTnLst>
+                                    <p:set>
+                                      <p:cBhvr>
+                                        <p:cTn id="6" dur="1" fill="hold">
+                                          <p:stCondLst>
+                                            <p:cond delay="0"/>
+                                          </p:stCondLst>
+                                        </p:cTn>
+                                        <p:tgtEl>
+                                          <p:spTgt spid="5"/>
+                                        </p:tgtEl>
+                                        <p:attrNameLst>
+                                          <p:attrName>style.visibility</p:attrName>
+                                        </p:attrNameLst>
+                                      </p:cBhvr>
+                                      <p:to>
+                                        <p:strVal val="visible"/>
+                                      </p:to>
+                                    </p:set>
+                                  </p:childTnLst>
+                                </p:cTn>
+                              </p:par>
+                            </p:childTnLst>
+                          </p:cTn>
+                        </p:par>
+                      </p:childTnLst>
+                    </p:cTn>
+                  </p:par>
+                </p:childTnLst>
+              </p:cTn>
+              <p:prevCondLst>
+                <p:cond evt="onPrev" delay="0">
+                  <p:tgtEl>
+                    <p:sldTgt/>
+                  </p:tgtEl>
+                </p:cond>
+              </p:prevCondLst>
+              <p:nextCondLst>
+                <p:cond evt="onNext" delay="0">
+                  <p:tgtEl>
+                    <p:sldTgt/>
+                  </p:tgtEl>
+                </p:cond>
+              </p:nextCondLst>
+            </p:seq>
+          </p:childTnLst>
+        </p:cTn>
+      </p:par>
+    </p:tnLst>
+    <p:bldLst>
+      <p:bldP spid="5" grpId="0" animBg="1"/>
+    </p:bldLst>
+  </p:timing>
+</p:sld>
+</file>
+
+<file path=ppt/slides/slide59.xml><?xml version="1.0" encoding="utf-8"?>
+<p:sld xmlns:a="http://schemas.openxmlformats.org/drawingml/2006/main" xmlns:r="http://schemas.openxmlformats.org/officeDocument/2006/relationships" xmlns:p="http://schemas.openxmlformats.org/presentationml/2006/main">
+  <p:cSld>
+    <p:spTree>
+      <p:nvGrpSpPr>
+        <p:cNvPr id="1" name=""/>
+        <p:cNvGrpSpPr/>
+        <p:nvPr/>
+      </p:nvGrpSpPr>
+      <p:grpSpPr>
+        <a:xfrm>
+          <a:off x="0" y="0"/>
+          <a:ext cx="0" cy="0"/>
+          <a:chOff x="0" y="0"/>
+          <a:chExt cx="0" cy="0"/>
+        </a:xfrm>
+      </p:grpSpPr>
+      <p:sp>
+        <p:nvSpPr>
+          <p:cNvPr id="2" name="Title 1">
+            <a:extLst>
+              <a:ext uri="{FF2B5EF4-FFF2-40B4-BE49-F238E27FC236}">
+                <a16:creationId xmlns:a16="http://schemas.microsoft.com/office/drawing/2014/main" id="{22597127-255D-E990-EC62-F84C40508FDD}"/>
+              </a:ext>
+            </a:extLst>
+          </p:cNvPr>
+          <p:cNvSpPr>
+            <a:spLocks noGrp="1"/>
+          </p:cNvSpPr>
+          <p:nvPr>
+            <p:ph type="title"/>
+          </p:nvPr>
+        </p:nvSpPr>
+        <p:spPr/>
+        <p:txBody>
+          <a:bodyPr/>
+          <a:lstStyle/>
+          <a:p>
+            <a:r>
+              <a:rPr lang="en-US" dirty="0"/>
+              <a:t>Pointer to </a:t>
+            </a:r>
+            <a:r>
+              <a:rPr lang="en-US" dirty="0" err="1"/>
+              <a:t>IMPLementation</a:t>
+            </a:r>
+            <a:r>
+              <a:rPr lang="en-US" dirty="0"/>
+              <a:t> idiom (PIMPL)</a:t>
+            </a:r>
+            <a:endParaRPr lang="LID4096" dirty="0"/>
+          </a:p>
+        </p:txBody>
+      </p:sp>
+      <p:sp>
+        <p:nvSpPr>
+          <p:cNvPr id="3" name="Content Placeholder 2">
+            <a:extLst>
+              <a:ext uri="{FF2B5EF4-FFF2-40B4-BE49-F238E27FC236}">
+                <a16:creationId xmlns:a16="http://schemas.microsoft.com/office/drawing/2014/main" id="{BFC3B8FA-3708-5100-0EB8-21D5539B42F7}"/>
+              </a:ext>
+            </a:extLst>
+          </p:cNvPr>
+          <p:cNvSpPr>
+            <a:spLocks noGrp="1"/>
+          </p:cNvSpPr>
+          <p:nvPr>
+            <p:ph idx="1"/>
+          </p:nvPr>
+        </p:nvSpPr>
+        <p:spPr/>
+        <p:txBody>
+          <a:bodyPr/>
+          <a:lstStyle/>
+          <a:p>
+            <a:r>
+              <a:rPr lang="en-US" dirty="0"/>
+              <a:t>Interface holds pointer to implementation</a:t>
+            </a:r>
+          </a:p>
+          <a:p>
+            <a:endParaRPr lang="en-US" dirty="0"/>
+          </a:p>
+          <a:p>
+            <a:r>
+              <a:rPr lang="en-US" dirty="0"/>
+              <a:t>Advantages</a:t>
+            </a:r>
+          </a:p>
+          <a:p>
+            <a:pPr lvl="1"/>
+            <a:r>
+              <a:rPr lang="en-US" dirty="0"/>
+              <a:t>Decouple interface and implementation</a:t>
+            </a:r>
+          </a:p>
+          <a:p>
+            <a:pPr lvl="1"/>
+            <a:r>
+              <a:rPr lang="en-US" dirty="0"/>
+              <a:t>Easy to replace implementation (DIP)</a:t>
+            </a:r>
+          </a:p>
+          <a:p>
+            <a:pPr lvl="1"/>
+            <a:r>
+              <a:rPr lang="en-US" dirty="0"/>
+              <a:t>Reduces compile times (only implementation needs to be recompiled)</a:t>
+            </a:r>
+            <a:endParaRPr lang="LID4096" dirty="0"/>
+          </a:p>
+        </p:txBody>
+      </p:sp>
+      <p:sp>
+        <p:nvSpPr>
+          <p:cNvPr id="4" name="Slide Number Placeholder 3">
+            <a:extLst>
+              <a:ext uri="{FF2B5EF4-FFF2-40B4-BE49-F238E27FC236}">
+                <a16:creationId xmlns:a16="http://schemas.microsoft.com/office/drawing/2014/main" id="{E9E5189A-6FE9-10F7-635D-516D82FAD1C8}"/>
+              </a:ext>
+            </a:extLst>
+          </p:cNvPr>
+          <p:cNvSpPr>
+            <a:spLocks noGrp="1"/>
+          </p:cNvSpPr>
+          <p:nvPr>
+            <p:ph type="sldNum" sz="quarter" idx="12"/>
+          </p:nvPr>
+        </p:nvSpPr>
+        <p:spPr/>
+        <p:txBody>
+          <a:bodyPr/>
+          <a:lstStyle/>
+          <a:p>
+            <a:fld id="{FDB1AA33-DFBB-49AC-8CEE-23FFECEB5648}" type="slidenum">
+              <a:rPr lang="LID4096" smtClean="0"/>
+              <a:t>59</a:t>
             </a:fld>
             <a:endParaRPr lang="LID4096"/>
           </a:p>
@@ -25138,7 +25418,7 @@
 </p:sld>
 </file>
 
-<file path=ppt/slides/slide59.xml><?xml version="1.0" encoding="utf-8"?>
+<file path=ppt/slides/slide6.xml><?xml version="1.0" encoding="utf-8"?>
 <p:sld xmlns:a="http://schemas.openxmlformats.org/drawingml/2006/main" xmlns:r="http://schemas.openxmlformats.org/officeDocument/2006/relationships" xmlns:p="http://schemas.openxmlformats.org/presentationml/2006/main">
   <p:cSld>
     <p:spTree>
@@ -25160,7 +25440,7 @@
           <p:cNvPr id="2" name="Title 1">
             <a:extLst>
               <a:ext uri="{FF2B5EF4-FFF2-40B4-BE49-F238E27FC236}">
-                <a16:creationId xmlns:a16="http://schemas.microsoft.com/office/drawing/2014/main" id="{E2C7D3C9-E83D-9F0A-51F3-4512E47A1EF6}"/>
+                <a16:creationId xmlns:a16="http://schemas.microsoft.com/office/drawing/2014/main" id="{CD8A5471-A4D8-4F5E-B450-200A4C371BE2}"/>
               </a:ext>
             </a:extLst>
           </p:cNvPr>
@@ -25178,6 +25458,118 @@
           <a:p>
             <a:r>
               <a:rPr lang="en-US" dirty="0"/>
+              <a:t>Best practices</a:t>
+            </a:r>
+          </a:p>
+        </p:txBody>
+      </p:sp>
+      <p:sp>
+        <p:nvSpPr>
+          <p:cNvPr id="3" name="Text Placeholder 2">
+            <a:extLst>
+              <a:ext uri="{FF2B5EF4-FFF2-40B4-BE49-F238E27FC236}">
+                <a16:creationId xmlns:a16="http://schemas.microsoft.com/office/drawing/2014/main" id="{46302BE0-A82A-4DCE-87F1-E8BD131C79CD}"/>
+              </a:ext>
+            </a:extLst>
+          </p:cNvPr>
+          <p:cNvSpPr>
+            <a:spLocks noGrp="1"/>
+          </p:cNvSpPr>
+          <p:nvPr>
+            <p:ph type="body" idx="1"/>
+          </p:nvPr>
+        </p:nvSpPr>
+        <p:spPr/>
+        <p:txBody>
+          <a:bodyPr/>
+          <a:lstStyle/>
+          <a:p>
+            <a:endParaRPr lang="en-US"/>
+          </a:p>
+        </p:txBody>
+      </p:sp>
+      <p:sp>
+        <p:nvSpPr>
+          <p:cNvPr id="4" name="Slide Number Placeholder 3">
+            <a:extLst>
+              <a:ext uri="{FF2B5EF4-FFF2-40B4-BE49-F238E27FC236}">
+                <a16:creationId xmlns:a16="http://schemas.microsoft.com/office/drawing/2014/main" id="{D678DF20-6449-4B12-9A41-DCB2C682E0F0}"/>
+              </a:ext>
+            </a:extLst>
+          </p:cNvPr>
+          <p:cNvSpPr>
+            <a:spLocks noGrp="1"/>
+          </p:cNvSpPr>
+          <p:nvPr>
+            <p:ph type="sldNum" sz="quarter" idx="12"/>
+          </p:nvPr>
+        </p:nvSpPr>
+        <p:spPr/>
+        <p:txBody>
+          <a:bodyPr/>
+          <a:lstStyle/>
+          <a:p>
+            <a:fld id="{5A209D72-2E9D-49B0-8977-41DCCC66C0BB}" type="slidenum">
+              <a:rPr lang="nl-BE" smtClean="0"/>
+              <a:t>6</a:t>
+            </a:fld>
+            <a:endParaRPr lang="nl-BE"/>
+          </a:p>
+        </p:txBody>
+      </p:sp>
+    </p:spTree>
+    <p:extLst>
+      <p:ext uri="{BB962C8B-B14F-4D97-AF65-F5344CB8AC3E}">
+        <p14:creationId xmlns:p14="http://schemas.microsoft.com/office/powerpoint/2010/main" val="2154523888"/>
+      </p:ext>
+    </p:extLst>
+  </p:cSld>
+  <p:clrMapOvr>
+    <a:masterClrMapping/>
+  </p:clrMapOvr>
+</p:sld>
+</file>
+
+<file path=ppt/slides/slide60.xml><?xml version="1.0" encoding="utf-8"?>
+<p:sld xmlns:a="http://schemas.openxmlformats.org/drawingml/2006/main" xmlns:r="http://schemas.openxmlformats.org/officeDocument/2006/relationships" xmlns:p="http://schemas.openxmlformats.org/presentationml/2006/main">
+  <p:cSld>
+    <p:spTree>
+      <p:nvGrpSpPr>
+        <p:cNvPr id="1" name=""/>
+        <p:cNvGrpSpPr/>
+        <p:nvPr/>
+      </p:nvGrpSpPr>
+      <p:grpSpPr>
+        <a:xfrm>
+          <a:off x="0" y="0"/>
+          <a:ext cx="0" cy="0"/>
+          <a:chOff x="0" y="0"/>
+          <a:chExt cx="0" cy="0"/>
+        </a:xfrm>
+      </p:grpSpPr>
+      <p:sp>
+        <p:nvSpPr>
+          <p:cNvPr id="2" name="Title 1">
+            <a:extLst>
+              <a:ext uri="{FF2B5EF4-FFF2-40B4-BE49-F238E27FC236}">
+                <a16:creationId xmlns:a16="http://schemas.microsoft.com/office/drawing/2014/main" id="{E2C7D3C9-E83D-9F0A-51F3-4512E47A1EF6}"/>
+              </a:ext>
+            </a:extLst>
+          </p:cNvPr>
+          <p:cNvSpPr>
+            <a:spLocks noGrp="1"/>
+          </p:cNvSpPr>
+          <p:nvPr>
+            <p:ph type="title"/>
+          </p:nvPr>
+        </p:nvSpPr>
+        <p:spPr/>
+        <p:txBody>
+          <a:bodyPr/>
+          <a:lstStyle/>
+          <a:p>
+            <a:r>
+              <a:rPr lang="en-US" dirty="0"/>
               <a:t>Resource Acquisition Is Initialization (RAII)</a:t>
             </a:r>
             <a:endParaRPr lang="LID4096" dirty="0"/>
@@ -25327,7 +25719,7 @@
           <a:p>
             <a:fld id="{FDB1AA33-DFBB-49AC-8CEE-23FFECEB5648}" type="slidenum">
               <a:rPr lang="LID4096" smtClean="0"/>
-              <a:t>59</a:t>
+              <a:t>60</a:t>
             </a:fld>
             <a:endParaRPr lang="LID4096"/>
           </a:p>
@@ -25393,290 +25785,6 @@
 </p:sld>
 </file>
 
-<file path=ppt/slides/slide6.xml><?xml version="1.0" encoding="utf-8"?>
-<p:sld xmlns:a="http://schemas.openxmlformats.org/drawingml/2006/main" xmlns:r="http://schemas.openxmlformats.org/officeDocument/2006/relationships" xmlns:p="http://schemas.openxmlformats.org/presentationml/2006/main">
-  <p:cSld>
-    <p:spTree>
-      <p:nvGrpSpPr>
-        <p:cNvPr id="1" name=""/>
-        <p:cNvGrpSpPr/>
-        <p:nvPr/>
-      </p:nvGrpSpPr>
-      <p:grpSpPr>
-        <a:xfrm>
-          <a:off x="0" y="0"/>
-          <a:ext cx="0" cy="0"/>
-          <a:chOff x="0" y="0"/>
-          <a:chExt cx="0" cy="0"/>
-        </a:xfrm>
-      </p:grpSpPr>
-      <p:sp>
-        <p:nvSpPr>
-          <p:cNvPr id="2" name="Title 1">
-            <a:extLst>
-              <a:ext uri="{FF2B5EF4-FFF2-40B4-BE49-F238E27FC236}">
-                <a16:creationId xmlns:a16="http://schemas.microsoft.com/office/drawing/2014/main" id="{CD8A5471-A4D8-4F5E-B450-200A4C371BE2}"/>
-              </a:ext>
-            </a:extLst>
-          </p:cNvPr>
-          <p:cNvSpPr>
-            <a:spLocks noGrp="1"/>
-          </p:cNvSpPr>
-          <p:nvPr>
-            <p:ph type="title"/>
-          </p:nvPr>
-        </p:nvSpPr>
-        <p:spPr/>
-        <p:txBody>
-          <a:bodyPr/>
-          <a:lstStyle/>
-          <a:p>
-            <a:r>
-              <a:rPr lang="en-US" dirty="0"/>
-              <a:t>Best practices</a:t>
-            </a:r>
-          </a:p>
-        </p:txBody>
-      </p:sp>
-      <p:sp>
-        <p:nvSpPr>
-          <p:cNvPr id="3" name="Text Placeholder 2">
-            <a:extLst>
-              <a:ext uri="{FF2B5EF4-FFF2-40B4-BE49-F238E27FC236}">
-                <a16:creationId xmlns:a16="http://schemas.microsoft.com/office/drawing/2014/main" id="{46302BE0-A82A-4DCE-87F1-E8BD131C79CD}"/>
-              </a:ext>
-            </a:extLst>
-          </p:cNvPr>
-          <p:cNvSpPr>
-            <a:spLocks noGrp="1"/>
-          </p:cNvSpPr>
-          <p:nvPr>
-            <p:ph type="body" idx="1"/>
-          </p:nvPr>
-        </p:nvSpPr>
-        <p:spPr/>
-        <p:txBody>
-          <a:bodyPr/>
-          <a:lstStyle/>
-          <a:p>
-            <a:endParaRPr lang="en-US"/>
-          </a:p>
-        </p:txBody>
-      </p:sp>
-      <p:sp>
-        <p:nvSpPr>
-          <p:cNvPr id="4" name="Slide Number Placeholder 3">
-            <a:extLst>
-              <a:ext uri="{FF2B5EF4-FFF2-40B4-BE49-F238E27FC236}">
-                <a16:creationId xmlns:a16="http://schemas.microsoft.com/office/drawing/2014/main" id="{D678DF20-6449-4B12-9A41-DCB2C682E0F0}"/>
-              </a:ext>
-            </a:extLst>
-          </p:cNvPr>
-          <p:cNvSpPr>
-            <a:spLocks noGrp="1"/>
-          </p:cNvSpPr>
-          <p:nvPr>
-            <p:ph type="sldNum" sz="quarter" idx="12"/>
-          </p:nvPr>
-        </p:nvSpPr>
-        <p:spPr/>
-        <p:txBody>
-          <a:bodyPr/>
-          <a:lstStyle/>
-          <a:p>
-            <a:fld id="{5A209D72-2E9D-49B0-8977-41DCCC66C0BB}" type="slidenum">
-              <a:rPr lang="nl-BE" smtClean="0"/>
-              <a:t>6</a:t>
-            </a:fld>
-            <a:endParaRPr lang="nl-BE"/>
-          </a:p>
-        </p:txBody>
-      </p:sp>
-    </p:spTree>
-    <p:extLst>
-      <p:ext uri="{BB962C8B-B14F-4D97-AF65-F5344CB8AC3E}">
-        <p14:creationId xmlns:p14="http://schemas.microsoft.com/office/powerpoint/2010/main" val="2154523888"/>
-      </p:ext>
-    </p:extLst>
-  </p:cSld>
-  <p:clrMapOvr>
-    <a:masterClrMapping/>
-  </p:clrMapOvr>
-</p:sld>
-</file>
-
-<file path=ppt/slides/slide60.xml><?xml version="1.0" encoding="utf-8"?>
-<p:sld xmlns:a="http://schemas.openxmlformats.org/drawingml/2006/main" xmlns:r="http://schemas.openxmlformats.org/officeDocument/2006/relationships" xmlns:p="http://schemas.openxmlformats.org/presentationml/2006/main">
-  <p:cSld>
-    <p:spTree>
-      <p:nvGrpSpPr>
-        <p:cNvPr id="1" name=""/>
-        <p:cNvGrpSpPr/>
-        <p:nvPr/>
-      </p:nvGrpSpPr>
-      <p:grpSpPr>
-        <a:xfrm>
-          <a:off x="0" y="0"/>
-          <a:ext cx="0" cy="0"/>
-          <a:chOff x="0" y="0"/>
-          <a:chExt cx="0" cy="0"/>
-        </a:xfrm>
-      </p:grpSpPr>
-      <p:sp>
-        <p:nvSpPr>
-          <p:cNvPr id="2" name="Title 1"/>
-          <p:cNvSpPr>
-            <a:spLocks noGrp="1"/>
-          </p:cNvSpPr>
-          <p:nvPr>
-            <p:ph type="title"/>
-          </p:nvPr>
-        </p:nvSpPr>
-        <p:spPr/>
-        <p:txBody>
-          <a:bodyPr/>
-          <a:lstStyle/>
-          <a:p>
-            <a:r>
-              <a:rPr lang="en-US" dirty="0"/>
-              <a:t>Further reading</a:t>
-            </a:r>
-            <a:endParaRPr lang="nl-BE" dirty="0"/>
-          </a:p>
-        </p:txBody>
-      </p:sp>
-      <p:sp>
-        <p:nvSpPr>
-          <p:cNvPr id="3" name="Content Placeholder 2"/>
-          <p:cNvSpPr>
-            <a:spLocks noGrp="1"/>
-          </p:cNvSpPr>
-          <p:nvPr>
-            <p:ph idx="1"/>
-          </p:nvPr>
-        </p:nvSpPr>
-        <p:spPr/>
-        <p:txBody>
-          <a:bodyPr/>
-          <a:lstStyle/>
-          <a:p>
-            <a:r>
-              <a:rPr lang="en-US" dirty="0"/>
-              <a:t>Erich Gamma, Richard Helm, Ralph Johnson and John </a:t>
-            </a:r>
-            <a:r>
-              <a:rPr lang="en-US" dirty="0" err="1"/>
-              <a:t>Vlissides</a:t>
-            </a:r>
-            <a:r>
-              <a:rPr lang="en-US" dirty="0"/>
-              <a:t> (1994) </a:t>
-            </a:r>
-            <a:r>
-              <a:rPr lang="en-US" i="1" dirty="0"/>
-              <a:t>Design patterns: elements of reusable object-oriented software</a:t>
-            </a:r>
-            <a:r>
-              <a:rPr lang="en-US" dirty="0"/>
-              <a:t>, Addison-Wesley</a:t>
-            </a:r>
-          </a:p>
-          <a:p>
-            <a:r>
-              <a:rPr lang="en-US" sz="2800" dirty="0"/>
-              <a:t>K</a:t>
-            </a:r>
-            <a:r>
-              <a:rPr lang="en-US" dirty="0"/>
-              <a:t>laus Iglberger (2022) </a:t>
-            </a:r>
-            <a:r>
-              <a:rPr lang="en-US" i="1" dirty="0"/>
-              <a:t>C++ software design</a:t>
-            </a:r>
-            <a:r>
-              <a:rPr lang="en-US" dirty="0"/>
-              <a:t>, O'Reilly Media</a:t>
-            </a:r>
-          </a:p>
-          <a:p>
-            <a:r>
-              <a:rPr lang="en-US" sz="2800" dirty="0"/>
-              <a:t>Timothy G. Mattson </a:t>
-            </a:r>
-            <a:r>
-              <a:rPr lang="en-US" dirty="0"/>
-              <a:t>and Beverly A. Sanders (2004) </a:t>
-            </a:r>
-            <a:r>
-              <a:rPr lang="en-US" i="1" dirty="0"/>
-              <a:t>Patterns for parallel programming</a:t>
-            </a:r>
-            <a:r>
-              <a:rPr lang="en-US" dirty="0"/>
-              <a:t>, Addison-Wesley</a:t>
-            </a:r>
-            <a:endParaRPr lang="en-US" sz="2800" dirty="0"/>
-          </a:p>
-          <a:p>
-            <a:endParaRPr lang="en-US" sz="2800" dirty="0"/>
-          </a:p>
-          <a:p>
-            <a:endParaRPr lang="nl-BE" dirty="0"/>
-          </a:p>
-        </p:txBody>
-      </p:sp>
-      <p:sp>
-        <p:nvSpPr>
-          <p:cNvPr id="4" name="Slide Number Placeholder 3"/>
-          <p:cNvSpPr>
-            <a:spLocks noGrp="1"/>
-          </p:cNvSpPr>
-          <p:nvPr>
-            <p:ph type="sldNum" sz="quarter" idx="12"/>
-          </p:nvPr>
-        </p:nvSpPr>
-        <p:spPr/>
-        <p:txBody>
-          <a:bodyPr/>
-          <a:lstStyle/>
-          <a:p>
-            <a:fld id="{5A209D72-2E9D-49B0-8977-41DCCC66C0BB}" type="slidenum">
-              <a:rPr lang="nl-BE">
-                <a:solidFill>
-                  <a:prstClr val="black">
-                    <a:tint val="75000"/>
-                  </a:prstClr>
-                </a:solidFill>
-                <a:latin typeface="Calibri"/>
-              </a:rPr>
-              <a:pPr/>
-              <a:t>60</a:t>
-            </a:fld>
-            <a:endParaRPr lang="nl-BE">
-              <a:solidFill>
-                <a:prstClr val="black">
-                  <a:tint val="75000"/>
-                </a:prstClr>
-              </a:solidFill>
-              <a:latin typeface="Calibri"/>
-            </a:endParaRPr>
-          </a:p>
-        </p:txBody>
-      </p:sp>
-    </p:spTree>
-    <p:extLst>
-      <p:ext uri="{BB962C8B-B14F-4D97-AF65-F5344CB8AC3E}">
-        <p14:creationId xmlns:p14="http://schemas.microsoft.com/office/powerpoint/2010/main" val="4100769943"/>
-      </p:ext>
-    </p:extLst>
-  </p:cSld>
-  <p:clrMapOvr>
-    <a:masterClrMapping/>
-  </p:clrMapOvr>
-</p:sld>
-</file>
-
 <file path=ppt/slides/slide61.xml><?xml version="1.0" encoding="utf-8"?>
 <p:sld xmlns:a="http://schemas.openxmlformats.org/drawingml/2006/main" xmlns:r="http://schemas.openxmlformats.org/officeDocument/2006/relationships" xmlns:p="http://schemas.openxmlformats.org/presentationml/2006/main">
   <p:cSld>
@@ -25696,13 +25804,7 @@
       </p:grpSpPr>
       <p:sp>
         <p:nvSpPr>
-          <p:cNvPr id="5" name="Title 4">
-            <a:extLst>
-              <a:ext uri="{FF2B5EF4-FFF2-40B4-BE49-F238E27FC236}">
-                <a16:creationId xmlns:a16="http://schemas.microsoft.com/office/drawing/2014/main" id="{B047AC09-4137-6264-6757-2F13914ACA28}"/>
-              </a:ext>
-            </a:extLst>
-          </p:cNvPr>
+          <p:cNvPr id="2" name="Title 1"/>
           <p:cNvSpPr>
             <a:spLocks noGrp="1"/>
           </p:cNvSpPr>
@@ -25717,26 +25819,20 @@
           <a:p>
             <a:r>
               <a:rPr lang="en-US" dirty="0"/>
-              <a:t>Functional approach</a:t>
-            </a:r>
-            <a:endParaRPr lang="LID4096" dirty="0"/>
-          </a:p>
-        </p:txBody>
-      </p:sp>
-      <p:sp>
-        <p:nvSpPr>
-          <p:cNvPr id="6" name="Text Placeholder 5">
-            <a:extLst>
-              <a:ext uri="{FF2B5EF4-FFF2-40B4-BE49-F238E27FC236}">
-                <a16:creationId xmlns:a16="http://schemas.microsoft.com/office/drawing/2014/main" id="{482D214C-4E56-C7D6-335F-9FBD13AF24C6}"/>
-              </a:ext>
-            </a:extLst>
-          </p:cNvPr>
+              <a:t>Further reading</a:t>
+            </a:r>
+            <a:endParaRPr lang="nl-BE" dirty="0"/>
+          </a:p>
+        </p:txBody>
+      </p:sp>
+      <p:sp>
+        <p:nvSpPr>
+          <p:cNvPr id="3" name="Content Placeholder 2"/>
           <p:cNvSpPr>
             <a:spLocks noGrp="1"/>
           </p:cNvSpPr>
           <p:nvPr>
-            <p:ph type="body" idx="1"/>
+            <p:ph idx="1"/>
           </p:nvPr>
         </p:nvSpPr>
         <p:spPr/>
@@ -25744,19 +25840,75 @@
           <a:bodyPr/>
           <a:lstStyle/>
           <a:p>
-            <a:endParaRPr lang="LID4096"/>
-          </a:p>
-        </p:txBody>
-      </p:sp>
-      <p:sp>
-        <p:nvSpPr>
-          <p:cNvPr id="4" name="Slide Number Placeholder 3">
-            <a:extLst>
-              <a:ext uri="{FF2B5EF4-FFF2-40B4-BE49-F238E27FC236}">
-                <a16:creationId xmlns:a16="http://schemas.microsoft.com/office/drawing/2014/main" id="{B66B75E1-EA21-65CD-B316-C1D421486EE7}"/>
-              </a:ext>
-            </a:extLst>
-          </p:cNvPr>
+            <a:r>
+              <a:rPr lang="en-US" dirty="0"/>
+              <a:t>Erich Gamma, Richard Helm, Ralph Johnson and John </a:t>
+            </a:r>
+            <a:r>
+              <a:rPr lang="en-US" dirty="0" err="1"/>
+              <a:t>Vlissides</a:t>
+            </a:r>
+            <a:r>
+              <a:rPr lang="en-US" dirty="0"/>
+              <a:t> (1994) </a:t>
+            </a:r>
+            <a:r>
+              <a:rPr lang="en-US" i="1" dirty="0"/>
+              <a:t>Design patterns: elements of reusable object-oriented software</a:t>
+            </a:r>
+            <a:r>
+              <a:rPr lang="en-US" dirty="0"/>
+              <a:t>, Addison-Wesley</a:t>
+            </a:r>
+          </a:p>
+          <a:p>
+            <a:r>
+              <a:rPr lang="en-US" sz="2800" dirty="0"/>
+              <a:t>K</a:t>
+            </a:r>
+            <a:r>
+              <a:rPr lang="en-US" dirty="0"/>
+              <a:t>laus Iglberger (2022) </a:t>
+            </a:r>
+            <a:r>
+              <a:rPr lang="en-US" i="1" dirty="0"/>
+              <a:t>C++ software design</a:t>
+            </a:r>
+            <a:r>
+              <a:rPr lang="en-US" dirty="0"/>
+              <a:t>, O'Reilly Media</a:t>
+            </a:r>
+          </a:p>
+          <a:p>
+            <a:r>
+              <a:rPr lang="en-US" sz="2800" dirty="0"/>
+              <a:t>Timothy G. Mattson </a:t>
+            </a:r>
+            <a:r>
+              <a:rPr lang="en-US" dirty="0"/>
+              <a:t>and Beverly A. Sanders (2004) </a:t>
+            </a:r>
+            <a:r>
+              <a:rPr lang="en-US" i="1" dirty="0"/>
+              <a:t>Patterns for parallel programming</a:t>
+            </a:r>
+            <a:r>
+              <a:rPr lang="en-US" dirty="0"/>
+              <a:t>, Addison-Wesley</a:t>
+            </a:r>
+            <a:endParaRPr lang="en-US" sz="2800" dirty="0"/>
+          </a:p>
+          <a:p>
+            <a:endParaRPr lang="en-US" sz="2800" dirty="0"/>
+          </a:p>
+          <a:p>
+            <a:endParaRPr lang="nl-BE" dirty="0"/>
+          </a:p>
+        </p:txBody>
+      </p:sp>
+      <p:sp>
+        <p:nvSpPr>
+          <p:cNvPr id="4" name="Slide Number Placeholder 3"/>
           <p:cNvSpPr>
             <a:spLocks noGrp="1"/>
           </p:cNvSpPr>
@@ -25769,18 +25921,33 @@
           <a:bodyPr/>
           <a:lstStyle/>
           <a:p>
-            <a:fld id="{FDB1AA33-DFBB-49AC-8CEE-23FFECEB5648}" type="slidenum">
-              <a:rPr lang="LID4096" smtClean="0"/>
+            <a:fld id="{5A209D72-2E9D-49B0-8977-41DCCC66C0BB}" type="slidenum">
+              <a:rPr lang="nl-BE">
+                <a:solidFill>
+                  <a:prstClr val="black">
+                    <a:tint val="75000"/>
+                  </a:prstClr>
+                </a:solidFill>
+                <a:latin typeface="Calibri"/>
+              </a:rPr>
+              <a:pPr/>
               <a:t>61</a:t>
             </a:fld>
-            <a:endParaRPr lang="LID4096"/>
+            <a:endParaRPr lang="nl-BE">
+              <a:solidFill>
+                <a:prstClr val="black">
+                  <a:tint val="75000"/>
+                </a:prstClr>
+              </a:solidFill>
+              <a:latin typeface="Calibri"/>
+            </a:endParaRPr>
           </a:p>
         </p:txBody>
       </p:sp>
     </p:spTree>
     <p:extLst>
       <p:ext uri="{BB962C8B-B14F-4D97-AF65-F5344CB8AC3E}">
-        <p14:creationId xmlns:p14="http://schemas.microsoft.com/office/powerpoint/2010/main" val="4080926898"/>
+        <p14:creationId xmlns:p14="http://schemas.microsoft.com/office/powerpoint/2010/main" val="4100769943"/>
       </p:ext>
     </p:extLst>
   </p:cSld>
@@ -25809,10 +25976,10 @@
       </p:grpSpPr>
       <p:sp>
         <p:nvSpPr>
-          <p:cNvPr id="2" name="Title 1">
-            <a:extLst>
-              <a:ext uri="{FF2B5EF4-FFF2-40B4-BE49-F238E27FC236}">
-                <a16:creationId xmlns:a16="http://schemas.microsoft.com/office/drawing/2014/main" id="{8F06986E-3696-7561-EFEC-42A2474822BD}"/>
+          <p:cNvPr id="5" name="Title 4">
+            <a:extLst>
+              <a:ext uri="{FF2B5EF4-FFF2-40B4-BE49-F238E27FC236}">
+                <a16:creationId xmlns:a16="http://schemas.microsoft.com/office/drawing/2014/main" id="{B047AC09-4137-6264-6757-2F13914ACA28}"/>
               </a:ext>
             </a:extLst>
           </p:cNvPr>
@@ -25830,6 +25997,119 @@
           <a:p>
             <a:r>
               <a:rPr lang="en-US" dirty="0"/>
+              <a:t>Functional approach</a:t>
+            </a:r>
+            <a:endParaRPr lang="LID4096" dirty="0"/>
+          </a:p>
+        </p:txBody>
+      </p:sp>
+      <p:sp>
+        <p:nvSpPr>
+          <p:cNvPr id="6" name="Text Placeholder 5">
+            <a:extLst>
+              <a:ext uri="{FF2B5EF4-FFF2-40B4-BE49-F238E27FC236}">
+                <a16:creationId xmlns:a16="http://schemas.microsoft.com/office/drawing/2014/main" id="{482D214C-4E56-C7D6-335F-9FBD13AF24C6}"/>
+              </a:ext>
+            </a:extLst>
+          </p:cNvPr>
+          <p:cNvSpPr>
+            <a:spLocks noGrp="1"/>
+          </p:cNvSpPr>
+          <p:nvPr>
+            <p:ph type="body" idx="1"/>
+          </p:nvPr>
+        </p:nvSpPr>
+        <p:spPr/>
+        <p:txBody>
+          <a:bodyPr/>
+          <a:lstStyle/>
+          <a:p>
+            <a:endParaRPr lang="LID4096"/>
+          </a:p>
+        </p:txBody>
+      </p:sp>
+      <p:sp>
+        <p:nvSpPr>
+          <p:cNvPr id="4" name="Slide Number Placeholder 3">
+            <a:extLst>
+              <a:ext uri="{FF2B5EF4-FFF2-40B4-BE49-F238E27FC236}">
+                <a16:creationId xmlns:a16="http://schemas.microsoft.com/office/drawing/2014/main" id="{B66B75E1-EA21-65CD-B316-C1D421486EE7}"/>
+              </a:ext>
+            </a:extLst>
+          </p:cNvPr>
+          <p:cNvSpPr>
+            <a:spLocks noGrp="1"/>
+          </p:cNvSpPr>
+          <p:nvPr>
+            <p:ph type="sldNum" sz="quarter" idx="12"/>
+          </p:nvPr>
+        </p:nvSpPr>
+        <p:spPr/>
+        <p:txBody>
+          <a:bodyPr/>
+          <a:lstStyle/>
+          <a:p>
+            <a:fld id="{FDB1AA33-DFBB-49AC-8CEE-23FFECEB5648}" type="slidenum">
+              <a:rPr lang="LID4096" smtClean="0"/>
+              <a:t>62</a:t>
+            </a:fld>
+            <a:endParaRPr lang="LID4096"/>
+          </a:p>
+        </p:txBody>
+      </p:sp>
+    </p:spTree>
+    <p:extLst>
+      <p:ext uri="{BB962C8B-B14F-4D97-AF65-F5344CB8AC3E}">
+        <p14:creationId xmlns:p14="http://schemas.microsoft.com/office/powerpoint/2010/main" val="4080926898"/>
+      </p:ext>
+    </p:extLst>
+  </p:cSld>
+  <p:clrMapOvr>
+    <a:masterClrMapping/>
+  </p:clrMapOvr>
+</p:sld>
+</file>
+
+<file path=ppt/slides/slide63.xml><?xml version="1.0" encoding="utf-8"?>
+<p:sld xmlns:a="http://schemas.openxmlformats.org/drawingml/2006/main" xmlns:r="http://schemas.openxmlformats.org/officeDocument/2006/relationships" xmlns:p="http://schemas.openxmlformats.org/presentationml/2006/main">
+  <p:cSld>
+    <p:spTree>
+      <p:nvGrpSpPr>
+        <p:cNvPr id="1" name=""/>
+        <p:cNvGrpSpPr/>
+        <p:nvPr/>
+      </p:nvGrpSpPr>
+      <p:grpSpPr>
+        <a:xfrm>
+          <a:off x="0" y="0"/>
+          <a:ext cx="0" cy="0"/>
+          <a:chOff x="0" y="0"/>
+          <a:chExt cx="0" cy="0"/>
+        </a:xfrm>
+      </p:grpSpPr>
+      <p:sp>
+        <p:nvSpPr>
+          <p:cNvPr id="2" name="Title 1">
+            <a:extLst>
+              <a:ext uri="{FF2B5EF4-FFF2-40B4-BE49-F238E27FC236}">
+                <a16:creationId xmlns:a16="http://schemas.microsoft.com/office/drawing/2014/main" id="{8F06986E-3696-7561-EFEC-42A2474822BD}"/>
+              </a:ext>
+            </a:extLst>
+          </p:cNvPr>
+          <p:cNvSpPr>
+            <a:spLocks noGrp="1"/>
+          </p:cNvSpPr>
+          <p:nvPr>
+            <p:ph type="title"/>
+          </p:nvPr>
+        </p:nvSpPr>
+        <p:spPr/>
+        <p:txBody>
+          <a:bodyPr/>
+          <a:lstStyle/>
+          <a:p>
+            <a:r>
+              <a:rPr lang="en-US" dirty="0"/>
               <a:t>Functional features in C++</a:t>
             </a:r>
             <a:endParaRPr lang="LID4096" dirty="0"/>
@@ -25906,7 +26186,7 @@
           <a:p>
             <a:fld id="{FDB1AA33-DFBB-49AC-8CEE-23FFECEB5648}" type="slidenum">
               <a:rPr lang="LID4096" smtClean="0"/>
-              <a:t>62</a:t>
+              <a:t>63</a:t>
             </a:fld>
             <a:endParaRPr lang="LID4096"/>
           </a:p>

</xml_diff>

<commit_message>
Add remark on C++ concepts in context of CRTP
</commit_message>
<xml_diff>
--- a/cpp_software_engineering.pptx
+++ b/cpp_software_engineering.pptx
@@ -22084,6 +22084,120 @@
           </a:p>
         </p:txBody>
       </p:sp>
+      <p:grpSp>
+        <p:nvGrpSpPr>
+          <p:cNvPr id="9" name="Group 8">
+            <a:extLst>
+              <a:ext uri="{FF2B5EF4-FFF2-40B4-BE49-F238E27FC236}">
+                <a16:creationId xmlns:a16="http://schemas.microsoft.com/office/drawing/2014/main" id="{1A966AA9-0C8D-890E-03A1-5667FAB96971}"/>
+              </a:ext>
+            </a:extLst>
+          </p:cNvPr>
+          <p:cNvGrpSpPr/>
+          <p:nvPr/>
+        </p:nvGrpSpPr>
+        <p:grpSpPr>
+          <a:xfrm>
+            <a:off x="7924800" y="1946787"/>
+            <a:ext cx="3531004" cy="830997"/>
+            <a:chOff x="7924800" y="1946787"/>
+            <a:chExt cx="3531004" cy="830997"/>
+          </a:xfrm>
+        </p:grpSpPr>
+        <p:sp>
+          <p:nvSpPr>
+            <p:cNvPr id="5" name="TextBox 4">
+              <a:extLst>
+                <a:ext uri="{FF2B5EF4-FFF2-40B4-BE49-F238E27FC236}">
+                  <a16:creationId xmlns:a16="http://schemas.microsoft.com/office/drawing/2014/main" id="{3C8B0E29-FB0A-D9F6-5D3F-123FA693BDCF}"/>
+                </a:ext>
+              </a:extLst>
+            </p:cNvPr>
+            <p:cNvSpPr txBox="1"/>
+            <p:nvPr/>
+          </p:nvSpPr>
+          <p:spPr>
+            <a:xfrm>
+              <a:off x="8962814" y="1946787"/>
+              <a:ext cx="2492990" cy="830997"/>
+            </a:xfrm>
+            <a:prstGeom prst="rect">
+              <a:avLst/>
+            </a:prstGeom>
+            <a:noFill/>
+            <a:ln>
+              <a:solidFill>
+                <a:schemeClr val="tx1"/>
+              </a:solidFill>
+            </a:ln>
+          </p:spPr>
+          <p:txBody>
+            <a:bodyPr wrap="none" rtlCol="0">
+              <a:spAutoFit/>
+            </a:bodyPr>
+            <a:lstStyle/>
+            <a:p>
+              <a:pPr algn="ctr"/>
+              <a:r>
+                <a:rPr lang="en-US" sz="2400" dirty="0"/>
+                <a:t>Can be done with</a:t>
+              </a:r>
+              <a:br>
+                <a:rPr lang="en-US" sz="2400" dirty="0"/>
+              </a:br>
+              <a:r>
+                <a:rPr lang="en-US" sz="2400" dirty="0"/>
+                <a:t>C++20 concepts</a:t>
+              </a:r>
+              <a:endParaRPr lang="LID4096" sz="2400" dirty="0"/>
+            </a:p>
+          </p:txBody>
+        </p:sp>
+        <p:cxnSp>
+          <p:nvCxnSpPr>
+            <p:cNvPr id="8" name="Straight Arrow Connector 7">
+              <a:extLst>
+                <a:ext uri="{FF2B5EF4-FFF2-40B4-BE49-F238E27FC236}">
+                  <a16:creationId xmlns:a16="http://schemas.microsoft.com/office/drawing/2014/main" id="{689CD235-1E2C-F44B-5DB6-71BA82E00016}"/>
+                </a:ext>
+              </a:extLst>
+            </p:cNvPr>
+            <p:cNvCxnSpPr>
+              <a:stCxn id="5" idx="1"/>
+            </p:cNvCxnSpPr>
+            <p:nvPr/>
+          </p:nvCxnSpPr>
+          <p:spPr>
+            <a:xfrm flipH="1">
+              <a:off x="7924800" y="2362286"/>
+              <a:ext cx="1038014" cy="223598"/>
+            </a:xfrm>
+            <a:prstGeom prst="straightConnector1">
+              <a:avLst/>
+            </a:prstGeom>
+            <a:ln>
+              <a:solidFill>
+                <a:schemeClr val="tx1"/>
+              </a:solidFill>
+              <a:tailEnd type="stealth" w="lg" len="lg"/>
+            </a:ln>
+          </p:spPr>
+          <p:style>
+            <a:lnRef idx="2">
+              <a:schemeClr val="accent1"/>
+            </a:lnRef>
+            <a:fillRef idx="0">
+              <a:schemeClr val="accent1"/>
+            </a:fillRef>
+            <a:effectRef idx="1">
+              <a:schemeClr val="accent1"/>
+            </a:effectRef>
+            <a:fontRef idx="minor">
+              <a:schemeClr val="tx1"/>
+            </a:fontRef>
+          </p:style>
+        </p:cxnSp>
+      </p:grpSp>
     </p:spTree>
     <p:extLst>
       <p:ext uri="{BB962C8B-B14F-4D97-AF65-F5344CB8AC3E}">
@@ -22115,7 +22229,7 @@
                             </p:stCondLst>
                             <p:childTnLst>
                               <p:par>
-                                <p:cTn id="5" presetID="1" presetClass="entr" presetSubtype="0" fill="hold" grpId="0" nodeType="clickEffect">
+                                <p:cTn id="5" presetID="1" presetClass="entr" presetSubtype="0" fill="hold" nodeType="clickEffect">
                                   <p:stCondLst>
                                     <p:cond delay="0"/>
                                   </p:stCondLst>
@@ -22123,6 +22237,51 @@
                                     <p:set>
                                       <p:cBhvr>
                                         <p:cTn id="6" dur="1" fill="hold">
+                                          <p:stCondLst>
+                                            <p:cond delay="0"/>
+                                          </p:stCondLst>
+                                        </p:cTn>
+                                        <p:tgtEl>
+                                          <p:spTgt spid="9"/>
+                                        </p:tgtEl>
+                                        <p:attrNameLst>
+                                          <p:attrName>style.visibility</p:attrName>
+                                        </p:attrNameLst>
+                                      </p:cBhvr>
+                                      <p:to>
+                                        <p:strVal val="visible"/>
+                                      </p:to>
+                                    </p:set>
+                                  </p:childTnLst>
+                                </p:cTn>
+                              </p:par>
+                            </p:childTnLst>
+                          </p:cTn>
+                        </p:par>
+                      </p:childTnLst>
+                    </p:cTn>
+                  </p:par>
+                  <p:par>
+                    <p:cTn id="7" fill="hold">
+                      <p:stCondLst>
+                        <p:cond delay="indefinite"/>
+                      </p:stCondLst>
+                      <p:childTnLst>
+                        <p:par>
+                          <p:cTn id="8" fill="hold">
+                            <p:stCondLst>
+                              <p:cond delay="0"/>
+                            </p:stCondLst>
+                            <p:childTnLst>
+                              <p:par>
+                                <p:cTn id="9" presetID="1" presetClass="entr" presetSubtype="0" fill="hold" grpId="0" nodeType="clickEffect">
+                                  <p:stCondLst>
+                                    <p:cond delay="0"/>
+                                  </p:stCondLst>
+                                  <p:childTnLst>
+                                    <p:set>
+                                      <p:cBhvr>
+                                        <p:cTn id="10" dur="1" fill="hold">
                                           <p:stCondLst>
                                             <p:cond delay="0"/>
                                           </p:stCondLst>

</xml_diff>